<commit_message>
exam-rules.md all-slides-with-answers.pdf all-slides.pdf code.zip text.pdf text.pptx
</commit_message>
<xml_diff>
--- a/ipsa/slides/text.pptx
+++ b/ipsa/slides/text.pptx
@@ -153,7 +153,7 @@
   <pc:docChgLst>
     <pc:chgData name="Gerth Stølting Brodal" userId="04ef4784-6591-4f86-a140-f5c3b108582a" providerId="ADAL" clId="{73BAC7D6-516A-44B5-B4B0-C7B08CA8B392}"/>
     <pc:docChg chg="undo custSel modSld">
-      <pc:chgData name="Gerth Stølting Brodal" userId="04ef4784-6591-4f86-a140-f5c3b108582a" providerId="ADAL" clId="{73BAC7D6-516A-44B5-B4B0-C7B08CA8B392}" dt="2026-04-22T07:29:47.136" v="103" actId="478"/>
+      <pc:chgData name="Gerth Stølting Brodal" userId="04ef4784-6591-4f86-a140-f5c3b108582a" providerId="ADAL" clId="{73BAC7D6-516A-44B5-B4B0-C7B08CA8B392}" dt="2026-04-22T10:25:28.205" v="117" actId="20577"/>
       <pc:docMkLst>
         <pc:docMk/>
       </pc:docMkLst>
@@ -758,7 +758,7 @@
         </pc:graphicFrameChg>
       </pc:sldChg>
       <pc:sldChg chg="addSp modSp mod modNotesTx">
-        <pc:chgData name="Gerth Stølting Brodal" userId="04ef4784-6591-4f86-a140-f5c3b108582a" providerId="ADAL" clId="{73BAC7D6-516A-44B5-B4B0-C7B08CA8B392}" dt="2026-04-22T06:38:18.835" v="94" actId="1076"/>
+        <pc:chgData name="Gerth Stølting Brodal" userId="04ef4784-6591-4f86-a140-f5c3b108582a" providerId="ADAL" clId="{73BAC7D6-516A-44B5-B4B0-C7B08CA8B392}" dt="2026-04-22T10:25:28.205" v="117" actId="20577"/>
         <pc:sldMkLst>
           <pc:docMk/>
           <pc:sldMk cId="3331187803" sldId="753"/>
@@ -836,11 +836,19 @@
           </ac:spMkLst>
         </pc:spChg>
         <pc:graphicFrameChg chg="modGraphic">
-          <ac:chgData name="Gerth Stølting Brodal" userId="04ef4784-6591-4f86-a140-f5c3b108582a" providerId="ADAL" clId="{73BAC7D6-516A-44B5-B4B0-C7B08CA8B392}" dt="2026-04-22T05:56:30.990" v="1" actId="790"/>
+          <ac:chgData name="Gerth Stølting Brodal" userId="04ef4784-6591-4f86-a140-f5c3b108582a" providerId="ADAL" clId="{73BAC7D6-516A-44B5-B4B0-C7B08CA8B392}" dt="2026-04-22T10:25:24.112" v="112" actId="20577"/>
           <ac:graphicFrameMkLst>
             <pc:docMk/>
             <pc:sldMk cId="3331187803" sldId="753"/>
             <ac:graphicFrameMk id="5" creationId="{00000000-0000-0000-0000-000000000000}"/>
+          </ac:graphicFrameMkLst>
+        </pc:graphicFrameChg>
+        <pc:graphicFrameChg chg="modGraphic">
+          <ac:chgData name="Gerth Stølting Brodal" userId="04ef4784-6591-4f86-a140-f5c3b108582a" providerId="ADAL" clId="{73BAC7D6-516A-44B5-B4B0-C7B08CA8B392}" dt="2026-04-22T10:25:28.205" v="117" actId="20577"/>
+          <ac:graphicFrameMkLst>
+            <pc:docMk/>
+            <pc:sldMk cId="3331187803" sldId="753"/>
+            <ac:graphicFrameMk id="7" creationId="{00000000-0000-0000-0000-000000000000}"/>
           </ac:graphicFrameMkLst>
         </pc:graphicFrameChg>
         <pc:picChg chg="add mod">
@@ -30517,7 +30525,7 @@
           <p:nvPr>
             <p:extLst>
               <p:ext uri="{D42A27DB-BD31-4B8C-83A1-F6EECF244321}">
-                <p14:modId xmlns:p14="http://schemas.microsoft.com/office/powerpoint/2010/main" val="2971387335"/>
+                <p14:modId xmlns:p14="http://schemas.microsoft.com/office/powerpoint/2010/main" val="98931927"/>
               </p:ext>
             </p:extLst>
           </p:nvPr>
@@ -30552,7 +30560,7 @@
                           <a:latin typeface="Courier New" panose="02070309020205020404" pitchFamily="49" charset="0"/>
                           <a:cs typeface="Courier New" panose="02070309020205020404" pitchFamily="49" charset="0"/>
                         </a:rPr>
-                        <a:t>river-utf8.py  (size 17</a:t>
+                        <a:t>river-utf8.txt  (size 17</a:t>
                       </a:r>
                       <a:r>
                         <a:rPr lang="en-US" sz="1400" b="1" baseline="0" noProof="0" dirty="0">
@@ -30727,7 +30735,7 @@
           <p:nvPr>
             <p:extLst>
               <p:ext uri="{D42A27DB-BD31-4B8C-83A1-F6EECF244321}">
-                <p14:modId xmlns:p14="http://schemas.microsoft.com/office/powerpoint/2010/main" val="1983244684"/>
+                <p14:modId xmlns:p14="http://schemas.microsoft.com/office/powerpoint/2010/main" val="175600363"/>
               </p:ext>
             </p:extLst>
           </p:nvPr>
@@ -30758,11 +30766,18 @@
                     <a:lstStyle/>
                     <a:p>
                       <a:r>
+                        <a:rPr lang="en-US" sz="1400" b="1" noProof="0">
+                          <a:latin typeface="Courier New" panose="02070309020205020404" pitchFamily="49" charset="0"/>
+                          <a:cs typeface="Courier New" panose="02070309020205020404" pitchFamily="49" charset="0"/>
+                        </a:rPr>
+                        <a:t>river-windows1252.txt  </a:t>
+                      </a:r>
+                      <a:r>
                         <a:rPr lang="en-US" sz="1400" b="1" noProof="0" dirty="0">
                           <a:latin typeface="Courier New" panose="02070309020205020404" pitchFamily="49" charset="0"/>
                           <a:cs typeface="Courier New" panose="02070309020205020404" pitchFamily="49" charset="0"/>
                         </a:rPr>
-                        <a:t>river-windows1252.py  (size 13</a:t>
+                        <a:t>(size 13</a:t>
                       </a:r>
                       <a:r>
                         <a:rPr lang="en-US" sz="1400" b="1" baseline="0" noProof="0" dirty="0">

</xml_diff>